<commit_message>
Update PPT and README with authentic 4-dashboard Light Mode captures from live Tableau suite
</commit_message>
<xml_diff>
--- a/Presentation (PPT)/Presentation - EduVision_DV.pptx
+++ b/Presentation (PPT)/Presentation - EduVision_DV.pptx
@@ -4043,8 +4043,8 @@
         </p:blipFill>
         <p:spPr>
           <a:xfrm>
-            <a:off x="5029200" y="1371600"/>
-            <a:ext cx="6400800" cy="4846320"/>
+            <a:off x="4937760" y="1645920"/>
+            <a:ext cx="6583680" cy="3701519"/>
           </a:xfrm>
           <a:prstGeom prst="rect">
             <a:avLst/>
@@ -4215,8 +4215,8 @@
         </p:blipFill>
         <p:spPr>
           <a:xfrm>
-            <a:off x="5029200" y="1371600"/>
-            <a:ext cx="6400800" cy="4846320"/>
+            <a:off x="4937760" y="1645920"/>
+            <a:ext cx="6583680" cy="3701519"/>
           </a:xfrm>
           <a:prstGeom prst="rect">
             <a:avLst/>
@@ -4387,8 +4387,8 @@
         </p:blipFill>
         <p:spPr>
           <a:xfrm>
-            <a:off x="5029200" y="1371600"/>
-            <a:ext cx="6400800" cy="4846320"/>
+            <a:off x="4937760" y="1645920"/>
+            <a:ext cx="6583680" cy="3701519"/>
           </a:xfrm>
           <a:prstGeom prst="rect">
             <a:avLst/>
@@ -4559,8 +4559,8 @@
         </p:blipFill>
         <p:spPr>
           <a:xfrm>
-            <a:off x="5029200" y="1371600"/>
-            <a:ext cx="6400800" cy="4846320"/>
+            <a:off x="4937760" y="1645920"/>
+            <a:ext cx="6583680" cy="3701519"/>
           </a:xfrm>
           <a:prstGeom prst="rect">
             <a:avLst/>

</xml_diff>